<commit_message>
modify js file and create_index
</commit_message>
<xml_diff>
--- a/proposal/Now.pptx
+++ b/proposal/Now.pptx
@@ -224,7 +224,7 @@
           <a:p>
             <a:fld id="{169121A4-D034-4B95-BA56-F54B62625834}" type="datetimeFigureOut">
               <a:rPr lang="en-US" smtClean="0"/>
-              <a:t>6/30/2025</a:t>
+              <a:t>7/5/2025</a:t>
             </a:fld>
             <a:endParaRPr lang="en-US"/>
           </a:p>
@@ -1213,7 +1213,7 @@
           <a:p>
             <a:fld id="{858B9F6A-2317-43EC-B7D0-AC21F0A4DD4D}" type="datetime1">
               <a:rPr lang="en-US" smtClean="0"/>
-              <a:t>6/30/2025</a:t>
+              <a:t>7/5/2025</a:t>
             </a:fld>
             <a:endParaRPr lang="en-US"/>
           </a:p>
@@ -1464,7 +1464,7 @@
           <a:p>
             <a:fld id="{86D32692-D42D-4132-A883-450279537E0E}" type="datetime1">
               <a:rPr lang="en-US" smtClean="0"/>
-              <a:t>6/30/2025</a:t>
+              <a:t>7/5/2025</a:t>
             </a:fld>
             <a:endParaRPr lang="en-US"/>
           </a:p>
@@ -1778,7 +1778,7 @@
           <a:p>
             <a:fld id="{C2FBA39B-FE12-4534-AE17-C62ADD4B56D5}" type="datetime1">
               <a:rPr lang="en-US" smtClean="0"/>
-              <a:t>6/30/2025</a:t>
+              <a:t>7/5/2025</a:t>
             </a:fld>
             <a:endParaRPr lang="en-US"/>
           </a:p>
@@ -2119,7 +2119,7 @@
           <a:p>
             <a:fld id="{89988FDA-C202-4882-AAD1-EFA2B877E306}" type="datetime1">
               <a:rPr lang="en-US" smtClean="0"/>
-              <a:t>6/30/2025</a:t>
+              <a:t>7/5/2025</a:t>
             </a:fld>
             <a:endParaRPr lang="en-US"/>
           </a:p>
@@ -2433,7 +2433,7 @@
           <a:p>
             <a:fld id="{16A88FB1-37B5-4FC9-94C6-D7435509F6D1}" type="datetime1">
               <a:rPr lang="en-US" smtClean="0"/>
-              <a:t>6/30/2025</a:t>
+              <a:t>7/5/2025</a:t>
             </a:fld>
             <a:endParaRPr lang="en-US"/>
           </a:p>
@@ -2826,7 +2826,7 @@
           <a:p>
             <a:fld id="{4FDCC448-64A4-4494-95AD-D7B43D99AF3A}" type="datetime1">
               <a:rPr lang="en-US" smtClean="0"/>
-              <a:t>6/30/2025</a:t>
+              <a:t>7/5/2025</a:t>
             </a:fld>
             <a:endParaRPr lang="en-US"/>
           </a:p>
@@ -2996,7 +2996,7 @@
           <a:p>
             <a:fld id="{629669AB-AC16-4849-891A-CEDA657351B3}" type="datetime1">
               <a:rPr lang="en-US" smtClean="0"/>
-              <a:t>6/30/2025</a:t>
+              <a:t>7/5/2025</a:t>
             </a:fld>
             <a:endParaRPr lang="en-US"/>
           </a:p>
@@ -3176,7 +3176,7 @@
           <a:p>
             <a:fld id="{2BC53C81-A7BB-45A7-8EDD-C8D9EC8832AD}" type="datetime1">
               <a:rPr lang="en-US" smtClean="0"/>
-              <a:t>6/30/2025</a:t>
+              <a:t>7/5/2025</a:t>
             </a:fld>
             <a:endParaRPr lang="en-US"/>
           </a:p>
@@ -3352,7 +3352,7 @@
           <a:p>
             <a:fld id="{1764AFB1-A0D6-4024-B4C0-C404DBAFA618}" type="datetime1">
               <a:rPr lang="en-US" smtClean="0"/>
-              <a:t>6/30/2025</a:t>
+              <a:t>7/5/2025</a:t>
             </a:fld>
             <a:endParaRPr lang="en-US"/>
           </a:p>
@@ -3599,7 +3599,7 @@
           <a:p>
             <a:fld id="{BE43FB49-72F2-455E-A640-E9FD20BE7BB9}" type="datetime1">
               <a:rPr lang="en-US" smtClean="0"/>
-              <a:t>6/30/2025</a:t>
+              <a:t>7/5/2025</a:t>
             </a:fld>
             <a:endParaRPr lang="en-US"/>
           </a:p>
@@ -3831,7 +3831,7 @@
           <a:p>
             <a:fld id="{E9A7E116-9F29-409C-93F3-BA50F099E3F1}" type="datetime1">
               <a:rPr lang="en-US" smtClean="0"/>
-              <a:t>6/30/2025</a:t>
+              <a:t>7/5/2025</a:t>
             </a:fld>
             <a:endParaRPr lang="en-US"/>
           </a:p>
@@ -4205,7 +4205,7 @@
           <a:p>
             <a:fld id="{93401725-8A35-402E-8B39-4586124AFFA5}" type="datetime1">
               <a:rPr lang="en-US" smtClean="0"/>
-              <a:t>6/30/2025</a:t>
+              <a:t>7/5/2025</a:t>
             </a:fld>
             <a:endParaRPr lang="en-US"/>
           </a:p>
@@ -4328,7 +4328,7 @@
           <a:p>
             <a:fld id="{59B81631-824B-49C5-B00B-B2F1F5E3C206}" type="datetime1">
               <a:rPr lang="en-US" smtClean="0"/>
-              <a:t>6/30/2025</a:t>
+              <a:t>7/5/2025</a:t>
             </a:fld>
             <a:endParaRPr lang="en-US"/>
           </a:p>
@@ -4423,7 +4423,7 @@
           <a:p>
             <a:fld id="{B47B51F9-A9D6-41BA-B779-34C7E74EE098}" type="datetime1">
               <a:rPr lang="en-US" smtClean="0"/>
-              <a:t>6/30/2025</a:t>
+              <a:t>7/5/2025</a:t>
             </a:fld>
             <a:endParaRPr lang="en-US"/>
           </a:p>
@@ -4678,7 +4678,7 @@
           <a:p>
             <a:fld id="{033B259D-A5C4-4188-B72C-29D2987A1EEA}" type="datetime1">
               <a:rPr lang="en-US" smtClean="0"/>
-              <a:t>6/30/2025</a:t>
+              <a:t>7/5/2025</a:t>
             </a:fld>
             <a:endParaRPr lang="en-US"/>
           </a:p>
@@ -4941,7 +4941,7 @@
           <a:p>
             <a:fld id="{E7079F9B-1F9A-41CE-9B8C-9E239D0CF92F}" type="datetime1">
               <a:rPr lang="en-US" smtClean="0"/>
-              <a:t>6/30/2025</a:t>
+              <a:t>7/5/2025</a:t>
             </a:fld>
             <a:endParaRPr lang="en-US"/>
           </a:p>
@@ -5684,7 +5684,7 @@
           <a:p>
             <a:fld id="{DA006DFD-2A21-4189-861C-66A70C0C1D70}" type="datetime1">
               <a:rPr lang="en-US" smtClean="0"/>
-              <a:t>6/30/2025</a:t>
+              <a:t>7/5/2025</a:t>
             </a:fld>
             <a:endParaRPr lang="en-US"/>
           </a:p>
@@ -9178,7 +9178,7 @@
         <p:spPr>
           <a:xfrm>
             <a:off x="743463" y="1243786"/>
-            <a:ext cx="6876537" cy="3693319"/>
+            <a:ext cx="6876537" cy="2893100"/>
           </a:xfrm>
           <a:prstGeom prst="rect">
             <a:avLst/>
@@ -9286,27 +9286,18 @@
           </a:p>
           <a:p>
             <a:r>
+              <a:rPr lang="en-US" sz="2600" b="1" dirty="0">
+                <a:latin typeface="TH Sarabun New" panose="020B0500040200020003" pitchFamily="34" charset="-34"/>
+                <a:cs typeface="TH Sarabun New" panose="020B0500040200020003" pitchFamily="34" charset="-34"/>
+              </a:rPr>
+              <a:t>3</a:t>
+            </a:r>
+            <a:r>
               <a:rPr lang="th-TH" sz="2600" b="1" dirty="0">
                 <a:latin typeface="TH Sarabun New" panose="020B0500040200020003" pitchFamily="34" charset="-34"/>
                 <a:cs typeface="TH Sarabun New" panose="020B0500040200020003" pitchFamily="34" charset="-34"/>
               </a:rPr>
-              <a:t>3. </a:t>
-            </a:r>
-            <a:r>
-              <a:rPr lang="th-TH" sz="2600" dirty="0">
-                <a:latin typeface="TH Sarabun New" panose="020B0500040200020003" pitchFamily="34" charset="-34"/>
-                <a:cs typeface="TH Sarabun New" panose="020B0500040200020003" pitchFamily="34" charset="-34"/>
-              </a:rPr>
-              <a:t>เมื่อได้คำทั้งหมดมาแล้ว ทำการจับกลุ่ม เนื่องจากว่ารายงานที่มีทั้งหมดนั้นค่อนข้างเยอะแต่ จะเป็นกลุ่มคำที่คล้ายกัน</a:t>
-            </a:r>
-          </a:p>
-          <a:p>
-            <a:r>
-              <a:rPr lang="th-TH" sz="2600" b="1" dirty="0">
-                <a:latin typeface="TH Sarabun New" panose="020B0500040200020003" pitchFamily="34" charset="-34"/>
-                <a:cs typeface="TH Sarabun New" panose="020B0500040200020003" pitchFamily="34" charset="-34"/>
-              </a:rPr>
-              <a:t>4. </a:t>
+              <a:t>. </a:t>
             </a:r>
             <a:r>
               <a:rPr lang="th-TH" sz="2600" dirty="0">
@@ -13005,7 +12996,7 @@
                 <a:latin typeface="TH Sarabun New" panose="020B0500040200020003" pitchFamily="34" charset="-34"/>
                 <a:cs typeface="TH Sarabun New" panose="020B0500040200020003" pitchFamily="34" charset="-34"/>
               </a:rPr>
-              <a:t>การทดลองและวิธีการวิจัย</a:t>
+              <a:t>การทดลอง</a:t>
             </a:r>
             <a:br>
               <a:rPr lang="th-TH" sz="3400" b="0" i="0" u="none" strike="noStrike" baseline="0" dirty="0">
@@ -13227,98 +13218,6 @@
   <p:clrMapOvr>
     <a:masterClrMapping/>
   </p:clrMapOvr>
-  <p:timing>
-    <p:tnLst>
-      <p:par>
-        <p:cTn id="1" dur="indefinite" restart="never" nodeType="tmRoot">
-          <p:childTnLst>
-            <p:seq concurrent="1" nextAc="seek">
-              <p:cTn id="2" dur="indefinite" nodeType="mainSeq">
-                <p:childTnLst>
-                  <p:par>
-                    <p:cTn id="3" fill="hold">
-                      <p:stCondLst>
-                        <p:cond delay="indefinite"/>
-                        <p:cond evt="onBegin" delay="0">
-                          <p:tn val="2"/>
-                        </p:cond>
-                      </p:stCondLst>
-                      <p:childTnLst>
-                        <p:par>
-                          <p:cTn id="4" fill="hold">
-                            <p:stCondLst>
-                              <p:cond delay="0"/>
-                            </p:stCondLst>
-                            <p:childTnLst>
-                              <p:par>
-                                <p:cTn id="5" presetID="10" presetClass="entr" presetSubtype="0" fill="hold" grpId="0" nodeType="withEffect">
-                                  <p:stCondLst>
-                                    <p:cond delay="500"/>
-                                  </p:stCondLst>
-                                  <p:iterate type="lt">
-                                    <p:tmPct val="10000"/>
-                                  </p:iterate>
-                                  <p:childTnLst>
-                                    <p:set>
-                                      <p:cBhvr>
-                                        <p:cTn id="6" dur="1" fill="hold">
-                                          <p:stCondLst>
-                                            <p:cond delay="0"/>
-                                          </p:stCondLst>
-                                        </p:cTn>
-                                        <p:tgtEl>
-                                          <p:spTgt spid="2"/>
-                                        </p:tgtEl>
-                                        <p:attrNameLst>
-                                          <p:attrName>style.visibility</p:attrName>
-                                        </p:attrNameLst>
-                                      </p:cBhvr>
-                                      <p:to>
-                                        <p:strVal val="visible"/>
-                                      </p:to>
-                                    </p:set>
-                                    <p:animEffect transition="in" filter="fade">
-                                      <p:cBhvr>
-                                        <p:cTn id="7" dur="400"/>
-                                        <p:tgtEl>
-                                          <p:spTgt spid="2"/>
-                                        </p:tgtEl>
-                                      </p:cBhvr>
-                                    </p:animEffect>
-                                  </p:childTnLst>
-                                </p:cTn>
-                              </p:par>
-                            </p:childTnLst>
-                          </p:cTn>
-                        </p:par>
-                      </p:childTnLst>
-                    </p:cTn>
-                  </p:par>
-                </p:childTnLst>
-              </p:cTn>
-              <p:prevCondLst>
-                <p:cond evt="onPrev" delay="0">
-                  <p:tgtEl>
-                    <p:sldTgt/>
-                  </p:tgtEl>
-                </p:cond>
-              </p:prevCondLst>
-              <p:nextCondLst>
-                <p:cond evt="onNext" delay="0">
-                  <p:tgtEl>
-                    <p:sldTgt/>
-                  </p:tgtEl>
-                </p:cond>
-              </p:nextCondLst>
-            </p:seq>
-          </p:childTnLst>
-        </p:cTn>
-      </p:par>
-    </p:tnLst>
-    <p:bldLst>
-      <p:bldP spid="2" grpId="0"/>
-    </p:bldLst>
-  </p:timing>
 </p:sld>
 </file>
 
@@ -14252,16 +14151,6 @@
               </a:rPr>
               <a:t>การทดลอง</a:t>
             </a:r>
-            <a:r>
-              <a:rPr lang="th-TH" sz="2600" b="1" i="0" u="none" strike="noStrike" baseline="0" dirty="0">
-                <a:solidFill>
-                  <a:schemeClr val="tx1"/>
-                </a:solidFill>
-                <a:latin typeface="TH Sarabun New" panose="020B0500040200020003" pitchFamily="34" charset="-34"/>
-                <a:cs typeface="TH Sarabun New" panose="020B0500040200020003" pitchFamily="34" charset="-34"/>
-              </a:rPr>
-              <a:t>และวิธีการวิจัย</a:t>
-            </a:r>
             <a:endParaRPr lang="en-US" sz="2600" b="1" dirty="0">
               <a:solidFill>
                 <a:schemeClr val="tx1"/>
@@ -14700,16 +14589,6 @@
                 <a:cs typeface="TH Sarabun New" panose="020B0500040200020003" pitchFamily="34" charset="-34"/>
               </a:rPr>
               <a:t>การทดลอง</a:t>
-            </a:r>
-            <a:r>
-              <a:rPr lang="th-TH" sz="2600" b="1" i="0" u="none" strike="noStrike" baseline="0" dirty="0">
-                <a:solidFill>
-                  <a:schemeClr val="tx1"/>
-                </a:solidFill>
-                <a:latin typeface="TH Sarabun New" panose="020B0500040200020003" pitchFamily="34" charset="-34"/>
-                <a:cs typeface="TH Sarabun New" panose="020B0500040200020003" pitchFamily="34" charset="-34"/>
-              </a:rPr>
-              <a:t>และวิธีการวิจัย</a:t>
             </a:r>
             <a:endParaRPr lang="en-US" sz="2600" b="1" dirty="0">
               <a:solidFill>
@@ -15077,16 +14956,6 @@
                 <a:cs typeface="TH Sarabun New" panose="020B0500040200020003" pitchFamily="34" charset="-34"/>
               </a:rPr>
               <a:t>การทดลอง</a:t>
-            </a:r>
-            <a:r>
-              <a:rPr lang="th-TH" sz="2600" b="1" i="0" u="none" strike="noStrike" baseline="0" dirty="0">
-                <a:solidFill>
-                  <a:schemeClr val="tx1"/>
-                </a:solidFill>
-                <a:latin typeface="TH Sarabun New" panose="020B0500040200020003" pitchFamily="34" charset="-34"/>
-                <a:cs typeface="TH Sarabun New" panose="020B0500040200020003" pitchFamily="34" charset="-34"/>
-              </a:rPr>
-              <a:t>และวิธีการวิจัย</a:t>
             </a:r>
             <a:endParaRPr lang="en-US" sz="2600" b="1" dirty="0">
               <a:solidFill>
@@ -16011,7 +15880,7 @@
           <p:nvPr>
             <p:extLst>
               <p:ext uri="{D42A27DB-BD31-4B8C-83A1-F6EECF244321}">
-                <p14:modId xmlns:p14="http://schemas.microsoft.com/office/powerpoint/2010/main" val="729430066"/>
+                <p14:modId xmlns:p14="http://schemas.microsoft.com/office/powerpoint/2010/main" val="1267078393"/>
               </p:ext>
             </p:extLst>
           </p:nvPr>
@@ -17353,6 +17222,14 @@
                         </a:rPr>
                         <a:t>16</a:t>
                       </a:r>
+                      <a:r>
+                        <a:rPr lang="th-TH" sz="1600" kern="100" dirty="0">
+                          <a:effectLst/>
+                          <a:latin typeface="TH Sarabun New" panose="020B0500040200020003" pitchFamily="34" charset="-34"/>
+                          <a:cs typeface="TH Sarabun New" panose="020B0500040200020003" pitchFamily="34" charset="-34"/>
+                        </a:rPr>
+                        <a:t>2</a:t>
+                      </a:r>
                       <a:endParaRPr lang="en-US" sz="1600" kern="100" dirty="0">
                         <a:effectLst/>
                         <a:latin typeface="TH Sarabun New" panose="020B0500040200020003" pitchFamily="34" charset="-34"/>
@@ -19662,14 +19539,14 @@
           <p:nvPr>
             <p:extLst>
               <p:ext uri="{D42A27DB-BD31-4B8C-83A1-F6EECF244321}">
-                <p14:modId xmlns:p14="http://schemas.microsoft.com/office/powerpoint/2010/main" val="2578385921"/>
+                <p14:modId xmlns:p14="http://schemas.microsoft.com/office/powerpoint/2010/main" val="466020445"/>
               </p:ext>
             </p:extLst>
           </p:nvPr>
         </p:nvGraphicFramePr>
         <p:xfrm>
           <a:off x="7447314" y="570602"/>
-          <a:ext cx="4592286" cy="5913120"/>
+          <a:ext cx="4592286" cy="5632704"/>
         </p:xfrm>
         <a:graphic>
           <a:graphicData uri="http://schemas.openxmlformats.org/drawingml/2006/table">
@@ -19692,21 +19569,21 @@
                     </a:ext>
                   </a:extLst>
                 </a:gridCol>
-                <a:gridCol w="989218">
+                <a:gridCol w="908244">
                   <a:extLst>
                     <a:ext uri="{9D8B030D-6E8A-4147-A177-3AD203B41FA5}">
                       <a16:colId xmlns:a16="http://schemas.microsoft.com/office/drawing/2014/main" val="3133461771"/>
                     </a:ext>
                   </a:extLst>
                 </a:gridCol>
-                <a:gridCol w="713685">
+                <a:gridCol w="677333">
                   <a:extLst>
                     <a:ext uri="{9D8B030D-6E8A-4147-A177-3AD203B41FA5}">
                       <a16:colId xmlns:a16="http://schemas.microsoft.com/office/drawing/2014/main" val="1536015477"/>
                     </a:ext>
                   </a:extLst>
                 </a:gridCol>
-                <a:gridCol w="698861">
+                <a:gridCol w="816187">
                   <a:extLst>
                     <a:ext uri="{9D8B030D-6E8A-4147-A177-3AD203B41FA5}">
                       <a16:colId xmlns:a16="http://schemas.microsoft.com/office/drawing/2014/main" val="3484553436"/>
@@ -22731,7 +22608,14 @@
                       </a:endParaRPr>
                     </a:p>
                   </a:txBody>
-                  <a:tcPr marL="45640" marR="45640" marT="0" marB="0" anchor="ctr"/>
+                  <a:tcPr marL="45640" marR="45640" marT="0" marB="0" anchor="ctr">
+                    <a:solidFill>
+                      <a:schemeClr val="accent5">
+                        <a:lumMod val="60000"/>
+                        <a:lumOff val="40000"/>
+                      </a:schemeClr>
+                    </a:solidFill>
+                  </a:tcPr>
                 </a:tc>
                 <a:tc>
                   <a:txBody>
@@ -22766,7 +22650,14 @@
                       </a:endParaRPr>
                     </a:p>
                   </a:txBody>
-                  <a:tcPr marL="45640" marR="45640" marT="0" marB="0" anchor="b"/>
+                  <a:tcPr marL="45640" marR="45640" marT="0" marB="0" anchor="b">
+                    <a:solidFill>
+                      <a:schemeClr val="accent5">
+                        <a:lumMod val="60000"/>
+                        <a:lumOff val="40000"/>
+                      </a:schemeClr>
+                    </a:solidFill>
+                  </a:tcPr>
                 </a:tc>
                 <a:tc>
                   <a:txBody>
@@ -22801,7 +22692,14 @@
                       </a:endParaRPr>
                     </a:p>
                   </a:txBody>
-                  <a:tcPr marL="45640" marR="45640" marT="0" marB="0" anchor="b"/>
+                  <a:tcPr marL="45640" marR="45640" marT="0" marB="0" anchor="b">
+                    <a:solidFill>
+                      <a:schemeClr val="accent5">
+                        <a:lumMod val="60000"/>
+                        <a:lumOff val="40000"/>
+                      </a:schemeClr>
+                    </a:solidFill>
+                  </a:tcPr>
                 </a:tc>
                 <a:tc>
                   <a:txBody>
@@ -22836,7 +22734,14 @@
                       </a:endParaRPr>
                     </a:p>
                   </a:txBody>
-                  <a:tcPr marL="45640" marR="45640" marT="0" marB="0" anchor="b"/>
+                  <a:tcPr marL="45640" marR="45640" marT="0" marB="0" anchor="b">
+                    <a:solidFill>
+                      <a:schemeClr val="accent5">
+                        <a:lumMod val="60000"/>
+                        <a:lumOff val="40000"/>
+                      </a:schemeClr>
+                    </a:solidFill>
+                  </a:tcPr>
                 </a:tc>
                 <a:tc>
                   <a:txBody>
@@ -22871,7 +22776,14 @@
                       </a:endParaRPr>
                     </a:p>
                   </a:txBody>
-                  <a:tcPr marL="45640" marR="45640" marT="0" marB="0" anchor="b"/>
+                  <a:tcPr marL="45640" marR="45640" marT="0" marB="0" anchor="b">
+                    <a:solidFill>
+                      <a:schemeClr val="accent5">
+                        <a:lumMod val="60000"/>
+                        <a:lumOff val="40000"/>
+                      </a:schemeClr>
+                    </a:solidFill>
+                  </a:tcPr>
                 </a:tc>
                 <a:extLst>
                   <a:ext uri="{0D108BD9-81ED-4DB2-BD59-A6C34878D82A}">
@@ -23224,14 +23136,14 @@
           <p:nvPr>
             <p:extLst>
               <p:ext uri="{D42A27DB-BD31-4B8C-83A1-F6EECF244321}">
-                <p14:modId xmlns:p14="http://schemas.microsoft.com/office/powerpoint/2010/main" val="3050629402"/>
+                <p14:modId xmlns:p14="http://schemas.microsoft.com/office/powerpoint/2010/main" val="3954109291"/>
               </p:ext>
             </p:extLst>
           </p:nvPr>
         </p:nvGraphicFramePr>
         <p:xfrm>
-          <a:off x="1589495" y="1015136"/>
-          <a:ext cx="3403311" cy="5632704"/>
+          <a:off x="972170" y="1029757"/>
+          <a:ext cx="3762390" cy="5352288"/>
         </p:xfrm>
         <a:graphic>
           <a:graphicData uri="http://schemas.openxmlformats.org/drawingml/2006/table">
@@ -23247,28 +23159,28 @@
                     </a:ext>
                   </a:extLst>
                 </a:gridCol>
-                <a:gridCol w="487591">
+                <a:gridCol w="655395">
                   <a:extLst>
                     <a:ext uri="{9D8B030D-6E8A-4147-A177-3AD203B41FA5}">
                       <a16:colId xmlns:a16="http://schemas.microsoft.com/office/drawing/2014/main" val="2638650310"/>
                     </a:ext>
                   </a:extLst>
                 </a:gridCol>
-                <a:gridCol w="817116">
+                <a:gridCol w="758613">
                   <a:extLst>
                     <a:ext uri="{9D8B030D-6E8A-4147-A177-3AD203B41FA5}">
                       <a16:colId xmlns:a16="http://schemas.microsoft.com/office/drawing/2014/main" val="3929332037"/>
                     </a:ext>
                   </a:extLst>
                 </a:gridCol>
-                <a:gridCol w="436688">
+                <a:gridCol w="535094">
                   <a:extLst>
                     <a:ext uri="{9D8B030D-6E8A-4147-A177-3AD203B41FA5}">
                       <a16:colId xmlns:a16="http://schemas.microsoft.com/office/drawing/2014/main" val="2548810684"/>
                     </a:ext>
                   </a:extLst>
                 </a:gridCol>
-                <a:gridCol w="688521">
+                <a:gridCol w="839893">
                   <a:extLst>
                     <a:ext uri="{9D8B030D-6E8A-4147-A177-3AD203B41FA5}">
                       <a16:colId xmlns:a16="http://schemas.microsoft.com/office/drawing/2014/main" val="1080069844"/>
@@ -23365,7 +23277,7 @@
                         <a:buNone/>
                       </a:pPr>
                       <a:r>
-                        <a:rPr lang="en-US" sz="1600" kern="100">
+                        <a:rPr lang="en-US" sz="1600" kern="100" dirty="0">
                           <a:effectLst/>
                           <a:latin typeface="TH Sarabun New" panose="020B0500040200020003" pitchFamily="34" charset="-34"/>
                           <a:cs typeface="TH Sarabun New" panose="020B0500040200020003" pitchFamily="34" charset="-34"/>
@@ -23387,36 +23299,14 @@
                         <a:buNone/>
                       </a:pPr>
                       <a:r>
-                        <a:rPr lang="en-US" sz="1600" kern="100">
-                          <a:effectLst/>
-                          <a:latin typeface="TH Sarabun New" panose="020B0500040200020003" pitchFamily="34" charset="-34"/>
-                          <a:cs typeface="TH Sarabun New" panose="020B0500040200020003" pitchFamily="34" charset="-34"/>
-                        </a:rPr>
-                        <a:t>+</a:t>
-                      </a:r>
-                    </a:p>
-                    <a:p>
-                      <a:pPr marL="0" marR="0" indent="0" algn="ctr">
-                        <a:lnSpc>
-                          <a:spcPct val="115000"/>
-                        </a:lnSpc>
-                        <a:spcBef>
-                          <a:spcPts val="600"/>
-                        </a:spcBef>
-                        <a:spcAft>
-                          <a:spcPts val="600"/>
-                        </a:spcAft>
-                        <a:buNone/>
-                      </a:pPr>
-                      <a:r>
-                        <a:rPr lang="en-US" sz="1600" kern="100">
-                          <a:effectLst/>
-                          <a:latin typeface="TH Sarabun New" panose="020B0500040200020003" pitchFamily="34" charset="-34"/>
-                          <a:cs typeface="TH Sarabun New" panose="020B0500040200020003" pitchFamily="34" charset="-34"/>
-                        </a:rPr>
-                        <a:t> synonyms</a:t>
-                      </a:r>
-                      <a:endParaRPr lang="en-US" sz="1600" kern="100">
+                        <a:rPr lang="en-US" sz="1600" kern="100" dirty="0">
+                          <a:effectLst/>
+                          <a:latin typeface="TH Sarabun New" panose="020B0500040200020003" pitchFamily="34" charset="-34"/>
+                          <a:cs typeface="TH Sarabun New" panose="020B0500040200020003" pitchFamily="34" charset="-34"/>
+                        </a:rPr>
+                        <a:t>+ synonyms</a:t>
+                      </a:r>
+                      <a:endParaRPr lang="en-US" sz="1600" kern="100" dirty="0">
                         <a:effectLst/>
                         <a:latin typeface="TH Sarabun New" panose="020B0500040200020003" pitchFamily="34" charset="-34"/>
                         <a:ea typeface="Arial Unicode MS" panose="020B0604020202020204"/>
@@ -26145,7 +26035,7 @@
           <p:nvPr>
             <p:extLst>
               <p:ext uri="{D42A27DB-BD31-4B8C-83A1-F6EECF244321}">
-                <p14:modId xmlns:p14="http://schemas.microsoft.com/office/powerpoint/2010/main" val="2362765157"/>
+                <p14:modId xmlns:p14="http://schemas.microsoft.com/office/powerpoint/2010/main" val="360939739"/>
               </p:ext>
             </p:extLst>
           </p:nvPr>
@@ -29042,14 +28932,14 @@
                         <a:buNone/>
                       </a:pPr>
                       <a:r>
-                        <a:rPr lang="en-US" sz="1600" b="1" kern="100">
+                        <a:rPr lang="en-US" sz="1600" b="1" kern="100" dirty="0">
                           <a:effectLst/>
                           <a:latin typeface="TH Sarabun New" panose="020B0500040200020003" pitchFamily="34" charset="-34"/>
                           <a:cs typeface="TH Sarabun New" panose="020B0500040200020003" pitchFamily="34" charset="-34"/>
                         </a:rPr>
                         <a:t>Macro-average Precision@15</a:t>
                       </a:r>
-                      <a:endParaRPr lang="en-US" sz="1600" b="1" kern="100">
+                      <a:endParaRPr lang="en-US" sz="1600" b="1" kern="100" dirty="0">
                         <a:effectLst/>
                         <a:latin typeface="TH Sarabun New" panose="020B0500040200020003" pitchFamily="34" charset="-34"/>
                         <a:ea typeface="Arial Unicode MS" panose="020B0604020202020204"/>
@@ -29057,7 +28947,14 @@
                       </a:endParaRPr>
                     </a:p>
                   </a:txBody>
-                  <a:tcPr marL="43776" marR="43776" marT="0" marB="0" anchor="ctr"/>
+                  <a:tcPr marL="43776" marR="43776" marT="0" marB="0" anchor="ctr">
+                    <a:solidFill>
+                      <a:schemeClr val="accent3">
+                        <a:lumMod val="60000"/>
+                        <a:lumOff val="40000"/>
+                      </a:schemeClr>
+                    </a:solidFill>
+                  </a:tcPr>
                 </a:tc>
                 <a:tc>
                   <a:txBody>
@@ -29092,7 +28989,14 @@
                       </a:endParaRPr>
                     </a:p>
                   </a:txBody>
-                  <a:tcPr marL="43776" marR="43776" marT="0" marB="0" anchor="b"/>
+                  <a:tcPr marL="43776" marR="43776" marT="0" marB="0" anchor="b">
+                    <a:solidFill>
+                      <a:schemeClr val="accent3">
+                        <a:lumMod val="60000"/>
+                        <a:lumOff val="40000"/>
+                      </a:schemeClr>
+                    </a:solidFill>
+                  </a:tcPr>
                 </a:tc>
                 <a:tc>
                   <a:txBody>
@@ -29127,7 +29031,14 @@
                       </a:endParaRPr>
                     </a:p>
                   </a:txBody>
-                  <a:tcPr marL="43776" marR="43776" marT="0" marB="0" anchor="b"/>
+                  <a:tcPr marL="43776" marR="43776" marT="0" marB="0" anchor="b">
+                    <a:solidFill>
+                      <a:schemeClr val="accent3">
+                        <a:lumMod val="60000"/>
+                        <a:lumOff val="40000"/>
+                      </a:schemeClr>
+                    </a:solidFill>
+                  </a:tcPr>
                 </a:tc>
                 <a:tc>
                   <a:txBody>
@@ -29162,7 +29073,14 @@
                       </a:endParaRPr>
                     </a:p>
                   </a:txBody>
-                  <a:tcPr marL="43776" marR="43776" marT="0" marB="0" anchor="b"/>
+                  <a:tcPr marL="43776" marR="43776" marT="0" marB="0" anchor="b">
+                    <a:solidFill>
+                      <a:schemeClr val="accent3">
+                        <a:lumMod val="60000"/>
+                        <a:lumOff val="40000"/>
+                      </a:schemeClr>
+                    </a:solidFill>
+                  </a:tcPr>
                 </a:tc>
                 <a:tc>
                   <a:txBody>
@@ -29213,7 +29131,14 @@
                       </a:endParaRPr>
                     </a:p>
                   </a:txBody>
-                  <a:tcPr marL="43776" marR="43776" marT="0" marB="0" anchor="b"/>
+                  <a:tcPr marL="43776" marR="43776" marT="0" marB="0" anchor="b">
+                    <a:solidFill>
+                      <a:schemeClr val="accent3">
+                        <a:lumMod val="60000"/>
+                        <a:lumOff val="40000"/>
+                      </a:schemeClr>
+                    </a:solidFill>
+                  </a:tcPr>
                 </a:tc>
                 <a:extLst>
                   <a:ext uri="{0D108BD9-81ED-4DB2-BD59-A6C34878D82A}">
@@ -33267,12 +33192,6 @@
 </file>
 
 <file path=customXml/item2.xml><?xml version="1.0" encoding="utf-8"?>
-<p:properties xmlns:p="http://schemas.microsoft.com/office/2006/metadata/properties" xmlns:xsi="http://www.w3.org/2001/XMLSchema-instance" xmlns:pc="http://schemas.microsoft.com/office/infopath/2007/PartnerControls">
-  <documentManagement/>
-</p:properties>
-</file>
-
-<file path=customXml/item3.xml><?xml version="1.0" encoding="utf-8"?>
 <ct:contentTypeSchema xmlns:ct="http://schemas.microsoft.com/office/2006/metadata/contentType" xmlns:ma="http://schemas.microsoft.com/office/2006/metadata/properties/metaAttributes" ct:_="" ma:_="" ma:contentTypeName="Document" ma:contentTypeID="0x01010068D211ABF73E194F9552777674A819ED" ma:contentTypeVersion="5" ma:contentTypeDescription="Create a new document." ma:contentTypeScope="" ma:versionID="988169cf93fbee5749617ad429756e1b">
   <xsd:schema xmlns:xsd="http://www.w3.org/2001/XMLSchema" xmlns:xs="http://www.w3.org/2001/XMLSchema" xmlns:p="http://schemas.microsoft.com/office/2006/metadata/properties" xmlns:ns3="05f8cd53-000c-42cc-b8f1-6cc2179124ab" targetNamespace="http://schemas.microsoft.com/office/2006/metadata/properties" ma:root="true" ma:fieldsID="05a46acbac201a43f88172d233fa135e" ns3:_="">
     <xsd:import namespace="05f8cd53-000c-42cc-b8f1-6cc2179124ab"/>
@@ -33422,6 +33341,12 @@
 </ct:contentTypeSchema>
 </file>
 
+<file path=customXml/item3.xml><?xml version="1.0" encoding="utf-8"?>
+<p:properties xmlns:p="http://schemas.microsoft.com/office/2006/metadata/properties" xmlns:xsi="http://www.w3.org/2001/XMLSchema-instance" xmlns:pc="http://schemas.microsoft.com/office/infopath/2007/PartnerControls">
+  <documentManagement/>
+</p:properties>
+</file>
+
 <file path=customXml/itemProps1.xml><?xml version="1.0" encoding="utf-8"?>
 <ds:datastoreItem xmlns:ds="http://schemas.openxmlformats.org/officeDocument/2006/customXml" ds:itemID="{EEA3426A-D9CD-4D97-A56B-FC5574F7293D}">
   <ds:schemaRefs>
@@ -33431,22 +33356,6 @@
 </file>
 
 <file path=customXml/itemProps2.xml><?xml version="1.0" encoding="utf-8"?>
-<ds:datastoreItem xmlns:ds="http://schemas.openxmlformats.org/officeDocument/2006/customXml" ds:itemID="{B2C48F46-9B33-48DB-BECB-A211F1066C6C}">
-  <ds:schemaRefs>
-    <ds:schemaRef ds:uri="05f8cd53-000c-42cc-b8f1-6cc2179124ab"/>
-    <ds:schemaRef ds:uri="http://purl.org/dc/terms/"/>
-    <ds:schemaRef ds:uri="http://purl.org/dc/dcmitype/"/>
-    <ds:schemaRef ds:uri="http://schemas.microsoft.com/office/2006/metadata/properties"/>
-    <ds:schemaRef ds:uri="http://purl.org/dc/elements/1.1/"/>
-    <ds:schemaRef ds:uri="http://www.w3.org/XML/1998/namespace"/>
-    <ds:schemaRef ds:uri="http://schemas.microsoft.com/office/2006/documentManagement/types"/>
-    <ds:schemaRef ds:uri="http://schemas.microsoft.com/office/infopath/2007/PartnerControls"/>
-    <ds:schemaRef ds:uri="http://schemas.openxmlformats.org/package/2006/metadata/core-properties"/>
-  </ds:schemaRefs>
-</ds:datastoreItem>
-</file>
-
-<file path=customXml/itemProps3.xml><?xml version="1.0" encoding="utf-8"?>
 <ds:datastoreItem xmlns:ds="http://schemas.openxmlformats.org/officeDocument/2006/customXml" ds:itemID="{52F55AD6-1987-4420-ACFB-0D631240E859}">
   <ds:schemaRefs>
     <ds:schemaRef ds:uri="http://schemas.microsoft.com/office/2006/metadata/contentType"/>
@@ -33462,4 +33371,20 @@
     <ds:schemaRef ds:uri="http://schemas.microsoft.com/internal/obd"/>
   </ds:schemaRefs>
 </ds:datastoreItem>
+</file>
+
+<file path=customXml/itemProps3.xml><?xml version="1.0" encoding="utf-8"?>
+<ds:datastoreItem xmlns:ds="http://schemas.openxmlformats.org/officeDocument/2006/customXml" ds:itemID="{B2C48F46-9B33-48DB-BECB-A211F1066C6C}">
+  <ds:schemaRefs>
+    <ds:schemaRef ds:uri="05f8cd53-000c-42cc-b8f1-6cc2179124ab"/>
+    <ds:schemaRef ds:uri="http://purl.org/dc/terms/"/>
+    <ds:schemaRef ds:uri="http://purl.org/dc/dcmitype/"/>
+    <ds:schemaRef ds:uri="http://schemas.microsoft.com/office/2006/metadata/properties"/>
+    <ds:schemaRef ds:uri="http://purl.org/dc/elements/1.1/"/>
+    <ds:schemaRef ds:uri="http://www.w3.org/XML/1998/namespace"/>
+    <ds:schemaRef ds:uri="http://schemas.microsoft.com/office/2006/documentManagement/types"/>
+    <ds:schemaRef ds:uri="http://schemas.microsoft.com/office/infopath/2007/PartnerControls"/>
+    <ds:schemaRef ds:uri="http://schemas.openxmlformats.org/package/2006/metadata/core-properties"/>
+  </ds:schemaRefs>
+</ds:datastoreItem>
 </file>
</xml_diff>